<commit_message>
Update Module 4, 5, 6 and 8 slide decks
Co-Authored-By: Claude Opus 5.5 <noreply@anthropic.com>
</commit_message>
<xml_diff>
--- a/Module4_Demo_v1.0/Module4_Prompt_Engineering_Essentials.pptx
+++ b/Module4_Demo_v1.0/Module4_Prompt_Engineering_Essentials.pptx
@@ -5,7 +5,7 @@
     <p:sldMasterId id="2147483648" r:id="rId1"/>
   </p:sldMasterIdLst>
   <p:notesMasterIdLst>
-    <p:notesMasterId r:id="rId15"/>
+    <p:notesMasterId r:id="rId16"/>
   </p:notesMasterIdLst>
   <p:sldIdLst>
     <p:sldId id="256" r:id="rId2"/>
@@ -18,9 +18,10 @@
     <p:sldId id="263" r:id="rId9"/>
     <p:sldId id="264" r:id="rId10"/>
     <p:sldId id="265" r:id="rId11"/>
-    <p:sldId id="266" r:id="rId12"/>
-    <p:sldId id="267" r:id="rId13"/>
-    <p:sldId id="268" r:id="rId14"/>
+    <p:sldId id="269" r:id="rId12"/>
+    <p:sldId id="270" r:id="rId13"/>
+    <p:sldId id="267" r:id="rId14"/>
+    <p:sldId id="268" r:id="rId15"/>
   </p:sldIdLst>
   <p:sldSz cx="12192000" cy="6858000"/>
   <p:notesSz cx="6858000" cy="12192000"/>
@@ -482,7 +483,7 @@
           <a:p>
             <a:fld id="{F7021451-1387-4CA6-816F-3879F97B5CBC}" type="slidenum">
               <a:rPr lang="en-US"/>
-              <a:t>11</a:t>
+              <a:t>13</a:t>
             </a:fld>
             <a:endParaRPr lang="en-US"/>
           </a:p>
@@ -566,91 +567,7 @@
           <a:p>
             <a:fld id="{F7021451-1387-4CA6-816F-3879F97B5CBC}" type="slidenum">
               <a:rPr lang="en-US"/>
-              <a:t>12</a:t>
-            </a:fld>
-            <a:endParaRPr lang="en-US"/>
-          </a:p>
-        </p:txBody>
-      </p:sp>
-    </p:spTree>
-    <p:extLst>
-      <p:ext uri="{BB962C8B-B14F-4D97-AF65-F5344CB8AC3E}">
-        <p14:creationId xmlns:p14="http://schemas.microsoft.com/office/powerpoint/2010/main" val="1024086991"/>
-      </p:ext>
-    </p:extLst>
-  </p:cSld>
-  <p:clrMapOvr>
-    <a:masterClrMapping/>
-  </p:clrMapOvr>
-</p:notes>
-</file>
-
-<file path=ppt/notesSlides/notesSlide13.xml><?xml version="1.0" encoding="utf-8"?>
-<p:notes xmlns:a="http://schemas.openxmlformats.org/drawingml/2006/main" xmlns:r="http://schemas.openxmlformats.org/officeDocument/2006/relationships" xmlns:p="http://schemas.openxmlformats.org/presentationml/2006/main">
-  <p:cSld>
-    <p:spTree>
-      <p:nvGrpSpPr>
-        <p:cNvPr id="1" name=""/>
-        <p:cNvGrpSpPr/>
-        <p:nvPr/>
-      </p:nvGrpSpPr>
-      <p:grpSpPr>
-        <a:xfrm>
-          <a:off x="0" y="0"/>
-          <a:ext cx="0" cy="0"/>
-          <a:chOff x="0" y="0"/>
-          <a:chExt cx="0" cy="0"/>
-        </a:xfrm>
-      </p:grpSpPr>
-      <p:sp>
-        <p:nvSpPr>
-          <p:cNvPr id="2" name="Slide Image Placeholder 1"/>
-          <p:cNvSpPr>
-            <a:spLocks noGrp="1" noRot="1" noChangeAspect="1"/>
-          </p:cNvSpPr>
-          <p:nvPr>
-            <p:ph type="sldImg"/>
-          </p:nvPr>
-        </p:nvSpPr>
-        <p:spPr/>
-      </p:sp>
-      <p:sp>
-        <p:nvSpPr>
-          <p:cNvPr id="3" name="Notes Placeholder 2"/>
-          <p:cNvSpPr>
-            <a:spLocks noGrp="1"/>
-          </p:cNvSpPr>
-          <p:nvPr>
-            <p:ph type="body" idx="1"/>
-          </p:nvPr>
-        </p:nvSpPr>
-        <p:spPr/>
-        <p:txBody>
-          <a:bodyPr/>
-          <a:lstStyle/>
-          <a:p>
-            <a:endParaRPr lang="en-US" dirty="0"/>
-          </a:p>
-        </p:txBody>
-      </p:sp>
-      <p:sp>
-        <p:nvSpPr>
-          <p:cNvPr id="4" name="Slide Number Placeholder 3"/>
-          <p:cNvSpPr>
-            <a:spLocks noGrp="1"/>
-          </p:cNvSpPr>
-          <p:nvPr>
-            <p:ph type="sldNum" sz="quarter" idx="10"/>
-          </p:nvPr>
-        </p:nvSpPr>
-        <p:spPr/>
-        <p:txBody>
-          <a:bodyPr/>
-          <a:lstStyle/>
-          <a:p>
-            <a:fld id="{F7021451-1387-4CA6-816F-3879F97B5CBC}" type="slidenum">
-              <a:rPr lang="en-US"/>
-              <a:t>13</a:t>
+              <a:t>14</a:t>
             </a:fld>
             <a:endParaRPr lang="en-US"/>
           </a:p>
@@ -3183,7 +3100,7 @@
 
 <file path=ppt/slides/slide11.xml><?xml version="1.0" encoding="utf-8"?>
 <p:sld xmlns:a="http://schemas.openxmlformats.org/drawingml/2006/main" xmlns:r="http://schemas.openxmlformats.org/officeDocument/2006/relationships" xmlns:p="http://schemas.openxmlformats.org/presentationml/2006/main">
-  <p:cSld name="Slide 11">
+  <p:cSld>
     <p:spTree>
       <p:nvGrpSpPr>
         <p:cNvPr id="1" name=""/>
@@ -3198,183 +3115,30 @@
           <a:chExt cx="0" cy="0"/>
         </a:xfrm>
       </p:grpSpPr>
-      <p:sp>
-        <p:nvSpPr>
-          <p:cNvPr id="2" name="Text 0"/>
-          <p:cNvSpPr txBox="1"/>
-          <p:nvPr/>
-        </p:nvSpPr>
-        <p:spPr>
-          <a:xfrm>
-            <a:off x="548640" y="320040"/>
-            <a:ext cx="7315200" cy="320040"/>
-          </a:xfrm>
-          <a:prstGeom prst="rect">
-            <a:avLst/>
-          </a:prstGeom>
-          <a:noFill/>
-          <a:ln/>
-        </p:spPr>
-        <p:txBody>
-          <a:bodyPr wrap="square" lIns="0" tIns="0" rIns="0" bIns="0" rtlCol="0" anchor="ctr"/>
-          <a:lstStyle/>
-          <a:p>
-            <a:pPr marL="0" indent="0">
-              <a:buNone/>
-            </a:pPr>
-            <a:r>
-              <a:rPr lang="en-US" sz="1200" b="1" kern="0" spc="200" dirty="0">
-                <a:solidFill>
-                  <a:srgbClr val="F2A65A"/>
-                </a:solidFill>
-                <a:latin typeface="Calibri" pitchFamily="34" charset="0"/>
-                <a:ea typeface="Calibri" pitchFamily="34" charset="-122"/>
-                <a:cs typeface="Calibri" pitchFamily="34" charset="-120"/>
-              </a:rPr>
-              <a:t>SECTION 9</a:t>
-            </a:r>
-            <a:endParaRPr lang="en-US" sz="1200" dirty="0"/>
-          </a:p>
-        </p:txBody>
-      </p:sp>
-      <p:sp>
-        <p:nvSpPr>
-          <p:cNvPr id="3" name="Text 1"/>
-          <p:cNvSpPr txBox="1"/>
-          <p:nvPr/>
-        </p:nvSpPr>
-        <p:spPr>
-          <a:xfrm>
-            <a:off x="548640" y="594360"/>
-            <a:ext cx="10515600" cy="640080"/>
-          </a:xfrm>
-          <a:prstGeom prst="rect">
-            <a:avLst/>
-          </a:prstGeom>
-          <a:noFill/>
-          <a:ln/>
-        </p:spPr>
-        <p:txBody>
-          <a:bodyPr wrap="square" lIns="0" tIns="0" rIns="0" bIns="0" rtlCol="0" anchor="ctr"/>
-          <a:lstStyle/>
-          <a:p>
-            <a:pPr marL="0" indent="0">
-              <a:buNone/>
-            </a:pPr>
-            <a:r>
-              <a:rPr lang="en-US" sz="3200" b="1" dirty="0">
-                <a:solidFill>
-                  <a:srgbClr val="1B2A4A"/>
-                </a:solidFill>
-                <a:latin typeface="Cambria" pitchFamily="34" charset="0"/>
-                <a:ea typeface="Cambria" pitchFamily="34" charset="-122"/>
-                <a:cs typeface="Cambria" pitchFamily="34" charset="-120"/>
-              </a:rPr>
-              <a:t>Prompt Engineering Tools</a:t>
-            </a:r>
-            <a:endParaRPr lang="en-US" sz="3200" dirty="0"/>
-          </a:p>
-        </p:txBody>
-      </p:sp>
-      <p:sp>
-        <p:nvSpPr>
-          <p:cNvPr id="4" name="Text 2"/>
-          <p:cNvSpPr txBox="1"/>
-          <p:nvPr/>
-        </p:nvSpPr>
-        <p:spPr>
-          <a:xfrm>
-            <a:off x="548640" y="1234440"/>
-            <a:ext cx="10515600" cy="457200"/>
-          </a:xfrm>
-          <a:prstGeom prst="rect">
-            <a:avLst/>
-          </a:prstGeom>
-          <a:noFill/>
-          <a:ln/>
-        </p:spPr>
-        <p:txBody>
-          <a:bodyPr wrap="square" lIns="0" tIns="0" rIns="0" bIns="0" rtlCol="0" anchor="ctr"/>
-          <a:lstStyle/>
-          <a:p>
-            <a:pPr marL="0" indent="0">
-              <a:buNone/>
-            </a:pPr>
-            <a:r>
-              <a:rPr lang="en-US" sz="1350" dirty="0">
-                <a:solidFill>
-                  <a:srgbClr val="5B6B85"/>
-                </a:solidFill>
-                <a:latin typeface="Calibri" pitchFamily="34" charset="0"/>
-                <a:ea typeface="Calibri" pitchFamily="34" charset="-122"/>
-                <a:cs typeface="Calibri" pitchFamily="34" charset="-120"/>
-              </a:rPr>
-              <a:t>A sample of the ecosystem that has grown up around writing, testing, and running prompts at scale.</a:t>
-            </a:r>
-            <a:endParaRPr lang="en-US" sz="1350" dirty="0"/>
-          </a:p>
-        </p:txBody>
-      </p:sp>
-      <p:sp>
-        <p:nvSpPr>
-          <p:cNvPr id="5" name="Shape 3"/>
-          <p:cNvSpPr/>
-          <p:nvPr/>
-        </p:nvSpPr>
-        <p:spPr>
-          <a:xfrm>
-            <a:off x="548640" y="1965960"/>
-            <a:ext cx="2487168" cy="3566160"/>
-          </a:xfrm>
-          <a:prstGeom prst="roundRect">
-            <a:avLst>
-              <a:gd name="adj" fmla="val 3676"/>
-            </a:avLst>
-          </a:prstGeom>
-          <a:solidFill>
-            <a:srgbClr val="F7F9FC"/>
-          </a:solidFill>
-          <a:ln/>
-        </p:spPr>
-      </p:sp>
-      <p:sp>
-        <p:nvSpPr>
-          <p:cNvPr id="6" name="Shape 4"/>
-          <p:cNvSpPr/>
-          <p:nvPr/>
-        </p:nvSpPr>
-        <p:spPr>
-          <a:xfrm>
-            <a:off x="1449324" y="2258568"/>
-            <a:ext cx="685800" cy="685800"/>
-          </a:xfrm>
-          <a:prstGeom prst="ellipse">
-            <a:avLst/>
-          </a:prstGeom>
-          <a:solidFill>
-            <a:srgbClr val="1B2A4A"/>
-          </a:solidFill>
-          <a:ln/>
-        </p:spPr>
-      </p:sp>
       <p:pic>
         <p:nvPicPr>
-          <p:cNvPr id="7" name="Image 0" descr="/home/claude/icons/store_FFFFFF.png"/>
+          <p:cNvPr id="3" name="Picture 2">
+            <a:extLst>
+              <a:ext uri="{FF2B5EF4-FFF2-40B4-BE49-F238E27FC236}">
+                <a16:creationId xmlns:a16="http://schemas.microsoft.com/office/drawing/2014/main" id="{7EF7CD7D-5906-ED1E-38B3-49BC3662DED0}"/>
+              </a:ext>
+            </a:extLst>
+          </p:cNvPr>
           <p:cNvPicPr>
             <a:picLocks noChangeAspect="1"/>
           </p:cNvPicPr>
           <p:nvPr/>
         </p:nvPicPr>
         <p:blipFill>
-          <a:blip r:embed="rId3"/>
+          <a:blip r:embed="rId2"/>
           <a:stretch>
             <a:fillRect/>
           </a:stretch>
         </p:blipFill>
         <p:spPr>
           <a:xfrm>
-            <a:off x="1603629" y="2412873"/>
-            <a:ext cx="377190" cy="377190"/>
+            <a:off x="1780761" y="0"/>
+            <a:ext cx="10287000" cy="6858000"/>
           </a:xfrm>
           <a:prstGeom prst="rect">
             <a:avLst/>
@@ -3383,605 +3147,47 @@
       </p:pic>
       <p:sp>
         <p:nvSpPr>
-          <p:cNvPr id="8" name="Text 5"/>
-          <p:cNvSpPr txBox="1"/>
-          <p:nvPr/>
-        </p:nvSpPr>
-        <p:spPr>
-          <a:xfrm>
-            <a:off x="676656" y="3108960"/>
-            <a:ext cx="2231136" cy="411480"/>
-          </a:xfrm>
-          <a:prstGeom prst="rect">
-            <a:avLst/>
-          </a:prstGeom>
-          <a:noFill/>
-          <a:ln/>
-        </p:spPr>
-        <p:txBody>
-          <a:bodyPr wrap="square" lIns="0" tIns="0" rIns="0" bIns="0" rtlCol="0" anchor="ctr"/>
-          <a:lstStyle/>
-          <a:p>
-            <a:pPr marL="0" indent="0" algn="ctr">
-              <a:buNone/>
-            </a:pPr>
-            <a:r>
-              <a:rPr lang="en-US" sz="1450" b="1" dirty="0">
-                <a:solidFill>
-                  <a:srgbClr val="1B2A4A"/>
-                </a:solidFill>
-                <a:latin typeface="Cambria" pitchFamily="34" charset="0"/>
-                <a:ea typeface="Cambria" pitchFamily="34" charset="-122"/>
-                <a:cs typeface="Cambria" pitchFamily="34" charset="-120"/>
-              </a:rPr>
-              <a:t>PromptBase</a:t>
-            </a:r>
-            <a:endParaRPr lang="en-US" sz="1450" dirty="0"/>
-          </a:p>
-        </p:txBody>
-      </p:sp>
-      <p:sp>
-        <p:nvSpPr>
-          <p:cNvPr id="9" name="Text 6"/>
-          <p:cNvSpPr txBox="1"/>
-          <p:nvPr/>
-        </p:nvSpPr>
-        <p:spPr>
-          <a:xfrm>
-            <a:off x="731520" y="3566160"/>
-            <a:ext cx="2121408" cy="1737360"/>
-          </a:xfrm>
-          <a:prstGeom prst="rect">
-            <a:avLst/>
-          </a:prstGeom>
-          <a:noFill/>
-          <a:ln/>
-        </p:spPr>
-        <p:txBody>
-          <a:bodyPr wrap="square" lIns="0" tIns="0" rIns="0" bIns="0" rtlCol="0" anchor="ctr"/>
-          <a:lstStyle/>
-          <a:p>
-            <a:pPr marL="0" indent="0" algn="ctr">
-              <a:lnSpc>
-                <a:spcPct val="120000"/>
-              </a:lnSpc>
-              <a:buNone/>
-            </a:pPr>
-            <a:r>
-              <a:rPr lang="en-US" sz="1100" dirty="0">
-                <a:solidFill>
-                  <a:srgbClr val="5B6B85"/>
-                </a:solidFill>
-                <a:latin typeface="Calibri" pitchFamily="34" charset="0"/>
-                <a:ea typeface="Calibri" pitchFamily="34" charset="-122"/>
-                <a:cs typeface="Calibri" pitchFamily="34" charset="-120"/>
-              </a:rPr>
-              <a:t>A marketplace to browse, buy, and sell ready-made prompts for different use cases.</a:t>
-            </a:r>
-            <a:endParaRPr lang="en-US" sz="1100" dirty="0"/>
-          </a:p>
-        </p:txBody>
-      </p:sp>
-      <p:sp>
-        <p:nvSpPr>
-          <p:cNvPr id="10" name="Shape 7"/>
-          <p:cNvSpPr/>
-          <p:nvPr/>
-        </p:nvSpPr>
-        <p:spPr>
-          <a:xfrm>
-            <a:off x="3236976" y="1965960"/>
-            <a:ext cx="2487168" cy="3566160"/>
-          </a:xfrm>
-          <a:prstGeom prst="roundRect">
-            <a:avLst>
-              <a:gd name="adj" fmla="val 3676"/>
-            </a:avLst>
-          </a:prstGeom>
-          <a:solidFill>
-            <a:srgbClr val="F7F9FC"/>
-          </a:solidFill>
-          <a:ln/>
-        </p:spPr>
-      </p:sp>
-      <p:sp>
-        <p:nvSpPr>
-          <p:cNvPr id="11" name="Shape 8"/>
-          <p:cNvSpPr/>
-          <p:nvPr/>
-        </p:nvSpPr>
-        <p:spPr>
-          <a:xfrm>
-            <a:off x="4137660" y="2258568"/>
-            <a:ext cx="685800" cy="685800"/>
-          </a:xfrm>
-          <a:prstGeom prst="ellipse">
-            <a:avLst/>
-          </a:prstGeom>
-          <a:solidFill>
-            <a:srgbClr val="1B2A4A"/>
-          </a:solidFill>
-          <a:ln/>
-        </p:spPr>
-      </p:sp>
-      <p:pic>
-        <p:nvPicPr>
-          <p:cNvPr id="12" name="Image 1" descr="/home/claude/icons/cubes_FFFFFF.png"/>
-          <p:cNvPicPr>
-            <a:picLocks noChangeAspect="1"/>
-          </p:cNvPicPr>
-          <p:nvPr/>
-        </p:nvPicPr>
-        <p:blipFill>
-          <a:blip r:embed="rId4"/>
-          <a:stretch>
-            <a:fillRect/>
-          </a:stretch>
-        </p:blipFill>
-        <p:spPr>
-          <a:xfrm>
-            <a:off x="4291965" y="2412873"/>
-            <a:ext cx="377190" cy="377190"/>
-          </a:xfrm>
-          <a:prstGeom prst="rect">
-            <a:avLst/>
-          </a:prstGeom>
-        </p:spPr>
-      </p:pic>
-      <p:sp>
-        <p:nvSpPr>
-          <p:cNvPr id="13" name="Text 9"/>
-          <p:cNvSpPr txBox="1"/>
-          <p:nvPr/>
-        </p:nvSpPr>
-        <p:spPr>
-          <a:xfrm>
-            <a:off x="3364992" y="3108960"/>
-            <a:ext cx="2231136" cy="411480"/>
-          </a:xfrm>
-          <a:prstGeom prst="rect">
-            <a:avLst/>
-          </a:prstGeom>
-          <a:noFill/>
-          <a:ln/>
-        </p:spPr>
-        <p:txBody>
-          <a:bodyPr wrap="square" lIns="0" tIns="0" rIns="0" bIns="0" rtlCol="0" anchor="ctr"/>
-          <a:lstStyle/>
-          <a:p>
-            <a:pPr marL="0" indent="0" algn="ctr">
-              <a:buNone/>
-            </a:pPr>
-            <a:r>
-              <a:rPr lang="en-US" sz="1450" b="1" dirty="0">
-                <a:solidFill>
-                  <a:srgbClr val="1B2A4A"/>
-                </a:solidFill>
-                <a:latin typeface="Cambria" pitchFamily="34" charset="0"/>
-                <a:ea typeface="Cambria" pitchFamily="34" charset="-122"/>
-                <a:cs typeface="Cambria" pitchFamily="34" charset="-120"/>
-              </a:rPr>
-              <a:t>OpenPrompt</a:t>
-            </a:r>
-            <a:endParaRPr lang="en-US" sz="1450" dirty="0"/>
-          </a:p>
-        </p:txBody>
-      </p:sp>
-      <p:sp>
-        <p:nvSpPr>
-          <p:cNvPr id="14" name="Text 10"/>
-          <p:cNvSpPr txBox="1"/>
-          <p:nvPr/>
-        </p:nvSpPr>
-        <p:spPr>
-          <a:xfrm>
-            <a:off x="3419856" y="3566160"/>
-            <a:ext cx="2121408" cy="1737360"/>
-          </a:xfrm>
-          <a:prstGeom prst="rect">
-            <a:avLst/>
-          </a:prstGeom>
-          <a:noFill/>
-          <a:ln/>
-        </p:spPr>
-        <p:txBody>
-          <a:bodyPr wrap="square" lIns="0" tIns="0" rIns="0" bIns="0" rtlCol="0" anchor="ctr"/>
-          <a:lstStyle/>
-          <a:p>
-            <a:pPr marL="0" indent="0" algn="ctr">
-              <a:lnSpc>
-                <a:spcPct val="120000"/>
-              </a:lnSpc>
-              <a:buNone/>
-            </a:pPr>
-            <a:r>
-              <a:rPr lang="en-US" sz="1100" dirty="0">
-                <a:solidFill>
-                  <a:srgbClr val="5B6B85"/>
-                </a:solidFill>
-                <a:latin typeface="Calibri" pitchFamily="34" charset="0"/>
-                <a:ea typeface="Calibri" pitchFamily="34" charset="-122"/>
-                <a:cs typeface="Calibri" pitchFamily="34" charset="-120"/>
-              </a:rPr>
-              <a:t>An open-source framework for building and experimenting with prompt-based NLP pipelines.</a:t>
-            </a:r>
-            <a:endParaRPr lang="en-US" sz="1100" dirty="0"/>
-          </a:p>
-        </p:txBody>
-      </p:sp>
-      <p:sp>
-        <p:nvSpPr>
-          <p:cNvPr id="15" name="Shape 11"/>
-          <p:cNvSpPr/>
-          <p:nvPr/>
-        </p:nvSpPr>
-        <p:spPr>
-          <a:xfrm>
-            <a:off x="5925312" y="1965960"/>
-            <a:ext cx="2487168" cy="3566160"/>
-          </a:xfrm>
-          <a:prstGeom prst="roundRect">
-            <a:avLst>
-              <a:gd name="adj" fmla="val 3676"/>
-            </a:avLst>
-          </a:prstGeom>
-          <a:solidFill>
-            <a:srgbClr val="F7F9FC"/>
-          </a:solidFill>
-          <a:ln/>
-        </p:spPr>
-      </p:sp>
-      <p:sp>
-        <p:nvSpPr>
-          <p:cNvPr id="16" name="Shape 12"/>
-          <p:cNvSpPr/>
-          <p:nvPr/>
-        </p:nvSpPr>
-        <p:spPr>
-          <a:xfrm>
-            <a:off x="6825996" y="2258568"/>
-            <a:ext cx="685800" cy="685800"/>
-          </a:xfrm>
-          <a:prstGeom prst="ellipse">
-            <a:avLst/>
-          </a:prstGeom>
-          <a:solidFill>
-            <a:srgbClr val="1B2A4A"/>
-          </a:solidFill>
-          <a:ln/>
-        </p:spPr>
-      </p:sp>
-      <p:pic>
-        <p:nvPicPr>
-          <p:cNvPr id="17" name="Image 2" descr="/home/claude/icons/magic_FFFFFF.png"/>
-          <p:cNvPicPr>
-            <a:picLocks noChangeAspect="1"/>
-          </p:cNvPicPr>
-          <p:nvPr/>
-        </p:nvPicPr>
-        <p:blipFill>
-          <a:blip r:embed="rId5"/>
-          <a:stretch>
-            <a:fillRect/>
-          </a:stretch>
-        </p:blipFill>
-        <p:spPr>
-          <a:xfrm>
-            <a:off x="6980301" y="2412873"/>
-            <a:ext cx="377190" cy="377190"/>
-          </a:xfrm>
-          <a:prstGeom prst="rect">
-            <a:avLst/>
-          </a:prstGeom>
-        </p:spPr>
-      </p:pic>
-      <p:sp>
-        <p:nvSpPr>
-          <p:cNvPr id="18" name="Text 13"/>
-          <p:cNvSpPr txBox="1"/>
-          <p:nvPr/>
-        </p:nvSpPr>
-        <p:spPr>
-          <a:xfrm>
-            <a:off x="6053328" y="3108960"/>
-            <a:ext cx="2231136" cy="411480"/>
-          </a:xfrm>
-          <a:prstGeom prst="rect">
-            <a:avLst/>
-          </a:prstGeom>
-          <a:noFill/>
-          <a:ln/>
-        </p:spPr>
-        <p:txBody>
-          <a:bodyPr wrap="square" lIns="0" tIns="0" rIns="0" bIns="0" rtlCol="0" anchor="ctr"/>
-          <a:lstStyle/>
-          <a:p>
-            <a:pPr marL="0" indent="0" algn="ctr">
-              <a:buNone/>
-            </a:pPr>
-            <a:r>
-              <a:rPr lang="en-US" sz="1450" b="1" dirty="0">
-                <a:solidFill>
-                  <a:srgbClr val="1B2A4A"/>
-                </a:solidFill>
-                <a:latin typeface="Cambria" pitchFamily="34" charset="0"/>
-                <a:ea typeface="Cambria" pitchFamily="34" charset="-122"/>
-                <a:cs typeface="Cambria" pitchFamily="34" charset="-120"/>
-              </a:rPr>
-              <a:t>PromptPerfect</a:t>
-            </a:r>
-            <a:endParaRPr lang="en-US" sz="1450" dirty="0"/>
-          </a:p>
-        </p:txBody>
-      </p:sp>
-      <p:sp>
-        <p:nvSpPr>
-          <p:cNvPr id="19" name="Text 14"/>
-          <p:cNvSpPr txBox="1"/>
-          <p:nvPr/>
-        </p:nvSpPr>
-        <p:spPr>
-          <a:xfrm>
-            <a:off x="6108192" y="3566160"/>
-            <a:ext cx="2121408" cy="1737360"/>
-          </a:xfrm>
-          <a:prstGeom prst="rect">
-            <a:avLst/>
-          </a:prstGeom>
-          <a:noFill/>
-          <a:ln/>
-        </p:spPr>
-        <p:txBody>
-          <a:bodyPr wrap="square" lIns="0" tIns="0" rIns="0" bIns="0" rtlCol="0" anchor="ctr"/>
-          <a:lstStyle/>
-          <a:p>
-            <a:pPr marL="0" indent="0" algn="ctr">
-              <a:lnSpc>
-                <a:spcPct val="120000"/>
-              </a:lnSpc>
-              <a:buNone/>
-            </a:pPr>
-            <a:r>
-              <a:rPr lang="en-US" sz="1100" dirty="0">
-                <a:solidFill>
-                  <a:srgbClr val="5B6B85"/>
-                </a:solidFill>
-                <a:latin typeface="Calibri" pitchFamily="34" charset="0"/>
-                <a:ea typeface="Calibri" pitchFamily="34" charset="-122"/>
-                <a:cs typeface="Calibri" pitchFamily="34" charset="-120"/>
-              </a:rPr>
-              <a:t>Automatically rewrites and tunes prompts to improve clarity and performance.</a:t>
-            </a:r>
-            <a:endParaRPr lang="en-US" sz="1100" dirty="0"/>
-          </a:p>
-        </p:txBody>
-      </p:sp>
-      <p:sp>
-        <p:nvSpPr>
-          <p:cNvPr id="20" name="Shape 15"/>
-          <p:cNvSpPr/>
-          <p:nvPr/>
-        </p:nvSpPr>
-        <p:spPr>
-          <a:xfrm>
-            <a:off x="8613648" y="1965960"/>
-            <a:ext cx="2487168" cy="3566160"/>
-          </a:xfrm>
-          <a:prstGeom prst="roundRect">
-            <a:avLst>
-              <a:gd name="adj" fmla="val 3676"/>
-            </a:avLst>
-          </a:prstGeom>
-          <a:solidFill>
-            <a:srgbClr val="F7F9FC"/>
-          </a:solidFill>
-          <a:ln/>
-        </p:spPr>
-      </p:sp>
-      <p:sp>
-        <p:nvSpPr>
-          <p:cNvPr id="21" name="Shape 16"/>
-          <p:cNvSpPr/>
-          <p:nvPr/>
-        </p:nvSpPr>
-        <p:spPr>
-          <a:xfrm>
-            <a:off x="9514332" y="2258568"/>
-            <a:ext cx="685800" cy="685800"/>
-          </a:xfrm>
-          <a:prstGeom prst="ellipse">
-            <a:avLst/>
-          </a:prstGeom>
-          <a:solidFill>
-            <a:srgbClr val="1B2A4A"/>
-          </a:solidFill>
-          <a:ln/>
-        </p:spPr>
-      </p:sp>
-      <p:pic>
-        <p:nvPicPr>
-          <p:cNvPr id="22" name="Image 3" descr="/home/claude/icons/chartline_FFFFFF.png"/>
-          <p:cNvPicPr>
-            <a:picLocks noChangeAspect="1"/>
-          </p:cNvPicPr>
-          <p:nvPr/>
-        </p:nvPicPr>
-        <p:blipFill>
-          <a:blip r:embed="rId6"/>
-          <a:stretch>
-            <a:fillRect/>
-          </a:stretch>
-        </p:blipFill>
-        <p:spPr>
-          <a:xfrm>
-            <a:off x="9668637" y="2412873"/>
-            <a:ext cx="377190" cy="377190"/>
-          </a:xfrm>
-          <a:prstGeom prst="rect">
-            <a:avLst/>
-          </a:prstGeom>
-        </p:spPr>
-      </p:pic>
-      <p:sp>
-        <p:nvSpPr>
-          <p:cNvPr id="23" name="Text 17"/>
-          <p:cNvSpPr txBox="1"/>
-          <p:nvPr/>
-        </p:nvSpPr>
-        <p:spPr>
-          <a:xfrm>
-            <a:off x="8741664" y="3108960"/>
-            <a:ext cx="2231136" cy="411480"/>
-          </a:xfrm>
-          <a:prstGeom prst="rect">
-            <a:avLst/>
-          </a:prstGeom>
-          <a:noFill/>
-          <a:ln/>
-        </p:spPr>
-        <p:txBody>
-          <a:bodyPr wrap="square" lIns="0" tIns="0" rIns="0" bIns="0" rtlCol="0" anchor="ctr"/>
-          <a:lstStyle/>
-          <a:p>
-            <a:pPr marL="0" indent="0" algn="ctr">
-              <a:buNone/>
-            </a:pPr>
-            <a:r>
-              <a:rPr lang="en-US" sz="1450" b="1" dirty="0">
-                <a:solidFill>
-                  <a:srgbClr val="1B2A4A"/>
-                </a:solidFill>
-                <a:latin typeface="Cambria" pitchFamily="34" charset="0"/>
-                <a:ea typeface="Cambria" pitchFamily="34" charset="-122"/>
-                <a:cs typeface="Cambria" pitchFamily="34" charset="-120"/>
-              </a:rPr>
-              <a:t>Agenta</a:t>
-            </a:r>
-            <a:endParaRPr lang="en-US" sz="1450" dirty="0"/>
-          </a:p>
-        </p:txBody>
-      </p:sp>
-      <p:sp>
-        <p:nvSpPr>
-          <p:cNvPr id="24" name="Text 18"/>
-          <p:cNvSpPr txBox="1"/>
-          <p:nvPr/>
-        </p:nvSpPr>
-        <p:spPr>
-          <a:xfrm>
-            <a:off x="8796528" y="3566160"/>
-            <a:ext cx="2121408" cy="1737360"/>
-          </a:xfrm>
-          <a:prstGeom prst="rect">
-            <a:avLst/>
-          </a:prstGeom>
-          <a:noFill/>
-          <a:ln/>
-        </p:spPr>
-        <p:txBody>
-          <a:bodyPr wrap="square" lIns="0" tIns="0" rIns="0" bIns="0" rtlCol="0" anchor="ctr"/>
-          <a:lstStyle/>
-          <a:p>
-            <a:pPr marL="0" indent="0" algn="ctr">
-              <a:lnSpc>
-                <a:spcPct val="120000"/>
-              </a:lnSpc>
-              <a:buNone/>
-            </a:pPr>
-            <a:r>
-              <a:rPr lang="en-US" sz="1100" dirty="0">
-                <a:solidFill>
-                  <a:srgbClr val="5B6B85"/>
-                </a:solidFill>
-                <a:latin typeface="Calibri" pitchFamily="34" charset="0"/>
-                <a:ea typeface="Calibri" pitchFamily="34" charset="-122"/>
-                <a:cs typeface="Calibri" pitchFamily="34" charset="-120"/>
-              </a:rPr>
-              <a:t>An open-source platform for prompt experimentation, evaluation, and observability.</a:t>
-            </a:r>
-            <a:endParaRPr lang="en-US" sz="1100" dirty="0"/>
-          </a:p>
-        </p:txBody>
-      </p:sp>
-      <p:sp>
-        <p:nvSpPr>
-          <p:cNvPr id="25" name="Text 19"/>
-          <p:cNvSpPr txBox="1"/>
-          <p:nvPr/>
-        </p:nvSpPr>
-        <p:spPr>
-          <a:xfrm>
-            <a:off x="548640" y="6537960"/>
-            <a:ext cx="5486400" cy="274320"/>
-          </a:xfrm>
-          <a:prstGeom prst="rect">
-            <a:avLst/>
-          </a:prstGeom>
-          <a:noFill/>
-          <a:ln/>
-        </p:spPr>
-        <p:txBody>
-          <a:bodyPr wrap="square" lIns="0" tIns="0" rIns="0" bIns="0" rtlCol="0" anchor="ctr"/>
-          <a:lstStyle/>
-          <a:p>
-            <a:pPr marL="0" indent="0">
-              <a:buNone/>
-            </a:pPr>
-            <a:r>
-              <a:rPr lang="en-US" sz="900" dirty="0">
-                <a:solidFill>
-                  <a:srgbClr val="5B6B85"/>
-                </a:solidFill>
-                <a:latin typeface="Calibri" pitchFamily="34" charset="0"/>
-                <a:ea typeface="Calibri" pitchFamily="34" charset="-122"/>
-                <a:cs typeface="Calibri" pitchFamily="34" charset="-120"/>
-              </a:rPr>
-              <a:t>Prompt Engineering Essentials</a:t>
-            </a:r>
-            <a:endParaRPr lang="en-US" sz="900" dirty="0"/>
-          </a:p>
-        </p:txBody>
-      </p:sp>
-      <p:sp>
-        <p:nvSpPr>
-          <p:cNvPr id="26" name="Text 20"/>
-          <p:cNvSpPr txBox="1"/>
-          <p:nvPr/>
-        </p:nvSpPr>
-        <p:spPr>
-          <a:xfrm>
-            <a:off x="11338560" y="6537960"/>
-            <a:ext cx="365760" cy="274320"/>
-          </a:xfrm>
-          <a:prstGeom prst="rect">
-            <a:avLst/>
-          </a:prstGeom>
-          <a:noFill/>
-          <a:ln/>
-        </p:spPr>
-        <p:txBody>
-          <a:bodyPr wrap="square" lIns="0" tIns="0" rIns="0" bIns="0" rtlCol="0" anchor="ctr"/>
-          <a:lstStyle/>
-          <a:p>
-            <a:pPr marL="0" indent="0" algn="r">
-              <a:buNone/>
-            </a:pPr>
-            <a:r>
-              <a:rPr lang="en-US" sz="900" dirty="0">
-                <a:solidFill>
-                  <a:srgbClr val="5B6B85"/>
-                </a:solidFill>
-                <a:latin typeface="Calibri" pitchFamily="34" charset="0"/>
-                <a:ea typeface="Calibri" pitchFamily="34" charset="-122"/>
-                <a:cs typeface="Calibri" pitchFamily="34" charset="-120"/>
-              </a:rPr>
-              <a:t>11</a:t>
-            </a:r>
-            <a:endParaRPr lang="en-US" sz="900" dirty="0"/>
+          <p:cNvPr id="4" name="TextBox 3">
+            <a:extLst>
+              <a:ext uri="{FF2B5EF4-FFF2-40B4-BE49-F238E27FC236}">
+                <a16:creationId xmlns:a16="http://schemas.microsoft.com/office/drawing/2014/main" id="{88178EDF-6CFA-DD2C-6458-205A3C37B6AE}"/>
+              </a:ext>
+            </a:extLst>
+          </p:cNvPr>
+          <p:cNvSpPr txBox="1"/>
+          <p:nvPr/>
+        </p:nvSpPr>
+        <p:spPr>
+          <a:xfrm>
+            <a:off x="46383" y="1497496"/>
+            <a:ext cx="1417982" cy="369332"/>
+          </a:xfrm>
+          <a:prstGeom prst="rect">
+            <a:avLst/>
+          </a:prstGeom>
+          <a:noFill/>
+        </p:spPr>
+        <p:txBody>
+          <a:bodyPr wrap="square" rtlCol="0">
+            <a:spAutoFit/>
+          </a:bodyPr>
+          <a:lstStyle/>
+          <a:p>
+            <a:pPr algn="ctr"/>
+            <a:r>
+              <a:rPr lang="en-IN" b="1" dirty="0"/>
+              <a:t>Embedding</a:t>
+            </a:r>
+            <a:endParaRPr lang="en-GB" b="1" dirty="0"/>
           </a:p>
         </p:txBody>
       </p:sp>
     </p:spTree>
+    <p:extLst>
+      <p:ext uri="{BB962C8B-B14F-4D97-AF65-F5344CB8AC3E}">
+        <p14:creationId xmlns:p14="http://schemas.microsoft.com/office/powerpoint/2010/main" val="1570743259"/>
+      </p:ext>
+    </p:extLst>
   </p:cSld>
   <p:clrMapOvr>
     <a:masterClrMapping/>
@@ -3990,6 +3196,109 @@
 </file>
 
 <file path=ppt/slides/slide12.xml><?xml version="1.0" encoding="utf-8"?>
+<p:sld xmlns:a="http://schemas.openxmlformats.org/drawingml/2006/main" xmlns:r="http://schemas.openxmlformats.org/officeDocument/2006/relationships" xmlns:p="http://schemas.openxmlformats.org/presentationml/2006/main">
+  <p:cSld>
+    <p:spTree>
+      <p:nvGrpSpPr>
+        <p:cNvPr id="1" name="">
+          <a:extLst>
+            <a:ext uri="{FF2B5EF4-FFF2-40B4-BE49-F238E27FC236}">
+              <a16:creationId xmlns:a16="http://schemas.microsoft.com/office/drawing/2014/main" id="{FD88F314-F5D4-780E-7784-8F72769EAFF6}"/>
+            </a:ext>
+          </a:extLst>
+        </p:cNvPr>
+        <p:cNvGrpSpPr/>
+        <p:nvPr/>
+      </p:nvGrpSpPr>
+      <p:grpSpPr>
+        <a:xfrm>
+          <a:off x="0" y="0"/>
+          <a:ext cx="0" cy="0"/>
+          <a:chOff x="0" y="0"/>
+          <a:chExt cx="0" cy="0"/>
+        </a:xfrm>
+      </p:grpSpPr>
+      <p:pic>
+        <p:nvPicPr>
+          <p:cNvPr id="4" name="Picture 3">
+            <a:extLst>
+              <a:ext uri="{FF2B5EF4-FFF2-40B4-BE49-F238E27FC236}">
+                <a16:creationId xmlns:a16="http://schemas.microsoft.com/office/drawing/2014/main" id="{D3C3D02E-9919-B4DE-2024-7D8F50BCB2CB}"/>
+              </a:ext>
+            </a:extLst>
+          </p:cNvPr>
+          <p:cNvPicPr>
+            <a:picLocks noChangeAspect="1"/>
+          </p:cNvPicPr>
+          <p:nvPr/>
+        </p:nvPicPr>
+        <p:blipFill>
+          <a:blip r:embed="rId2"/>
+          <a:stretch>
+            <a:fillRect/>
+          </a:stretch>
+        </p:blipFill>
+        <p:spPr>
+          <a:xfrm>
+            <a:off x="1767508" y="0"/>
+            <a:ext cx="10287000" cy="6858000"/>
+          </a:xfrm>
+          <a:prstGeom prst="rect">
+            <a:avLst/>
+          </a:prstGeom>
+        </p:spPr>
+      </p:pic>
+      <p:sp>
+        <p:nvSpPr>
+          <p:cNvPr id="6" name="TextBox 5">
+            <a:extLst>
+              <a:ext uri="{FF2B5EF4-FFF2-40B4-BE49-F238E27FC236}">
+                <a16:creationId xmlns:a16="http://schemas.microsoft.com/office/drawing/2014/main" id="{0F7180D2-AAD8-E2BD-3718-A303F2895728}"/>
+              </a:ext>
+            </a:extLst>
+          </p:cNvPr>
+          <p:cNvSpPr txBox="1"/>
+          <p:nvPr/>
+        </p:nvSpPr>
+        <p:spPr>
+          <a:xfrm>
+            <a:off x="46383" y="1497496"/>
+            <a:ext cx="1417982" cy="369332"/>
+          </a:xfrm>
+          <a:prstGeom prst="rect">
+            <a:avLst/>
+          </a:prstGeom>
+          <a:noFill/>
+        </p:spPr>
+        <p:txBody>
+          <a:bodyPr wrap="square" rtlCol="0">
+            <a:spAutoFit/>
+          </a:bodyPr>
+          <a:lstStyle/>
+          <a:p>
+            <a:pPr algn="ctr"/>
+            <a:r>
+              <a:rPr lang="en-IN" b="1" dirty="0"/>
+              <a:t>RAG</a:t>
+            </a:r>
+            <a:endParaRPr lang="en-GB" b="1" dirty="0"/>
+          </a:p>
+        </p:txBody>
+      </p:sp>
+    </p:spTree>
+    <p:extLst>
+      <p:ext uri="{BB962C8B-B14F-4D97-AF65-F5344CB8AC3E}">
+        <p14:creationId xmlns:p14="http://schemas.microsoft.com/office/powerpoint/2010/main" val="2920126369"/>
+      </p:ext>
+    </p:extLst>
+  </p:cSld>
+  <p:clrMapOvr>
+    <a:masterClrMapping/>
+  </p:clrMapOvr>
+</p:sld>
+</file>
+
+<file path=ppt/slides/slide13.xml><?xml version="1.0" encoding="utf-8"?>
 <p:sld xmlns:a="http://schemas.openxmlformats.org/drawingml/2006/main" xmlns:r="http://schemas.openxmlformats.org/officeDocument/2006/relationships" xmlns:p="http://schemas.openxmlformats.org/presentationml/2006/main">
   <p:cSld name="Slide 12">
     <p:spTree>
@@ -5198,7 +4507,7 @@
 </p:sld>
 </file>
 
-<file path=ppt/slides/slide13.xml><?xml version="1.0" encoding="utf-8"?>
+<file path=ppt/slides/slide14.xml><?xml version="1.0" encoding="utf-8"?>
 <p:sld xmlns:a="http://schemas.openxmlformats.org/drawingml/2006/main" xmlns:r="http://schemas.openxmlformats.org/officeDocument/2006/relationships" xmlns:p="http://schemas.openxmlformats.org/presentationml/2006/main">
   <p:cSld name="Slide 13">
     <p:bg>

</xml_diff>